<commit_message>
remade yao 2023 plot
</commit_message>
<xml_diff>
--- a/paper_plots/ppt12_concept_and_flowchart.pptx
+++ b/paper_plots/ppt12_concept_and_flowchart.pptx
@@ -243,7 +243,7 @@
           <a:p>
             <a:fld id="{EC25FAA8-77F2-5C42-A9DC-2A9BDE3DA24F}" type="datetimeFigureOut">
               <a:rPr lang="en-US" smtClean="0"/>
-              <a:t>6/25/25</a:t>
+              <a:t>9/11/25</a:t>
             </a:fld>
             <a:endParaRPr lang="en-US"/>
           </a:p>
@@ -413,7 +413,7 @@
           <a:p>
             <a:fld id="{EC25FAA8-77F2-5C42-A9DC-2A9BDE3DA24F}" type="datetimeFigureOut">
               <a:rPr lang="en-US" smtClean="0"/>
-              <a:t>6/25/25</a:t>
+              <a:t>9/11/25</a:t>
             </a:fld>
             <a:endParaRPr lang="en-US"/>
           </a:p>
@@ -593,7 +593,7 @@
           <a:p>
             <a:fld id="{EC25FAA8-77F2-5C42-A9DC-2A9BDE3DA24F}" type="datetimeFigureOut">
               <a:rPr lang="en-US" smtClean="0"/>
-              <a:t>6/25/25</a:t>
+              <a:t>9/11/25</a:t>
             </a:fld>
             <a:endParaRPr lang="en-US"/>
           </a:p>
@@ -763,7 +763,7 @@
           <a:p>
             <a:fld id="{EC25FAA8-77F2-5C42-A9DC-2A9BDE3DA24F}" type="datetimeFigureOut">
               <a:rPr lang="en-US" smtClean="0"/>
-              <a:t>6/25/25</a:t>
+              <a:t>9/11/25</a:t>
             </a:fld>
             <a:endParaRPr lang="en-US"/>
           </a:p>
@@ -1009,7 +1009,7 @@
           <a:p>
             <a:fld id="{EC25FAA8-77F2-5C42-A9DC-2A9BDE3DA24F}" type="datetimeFigureOut">
               <a:rPr lang="en-US" smtClean="0"/>
-              <a:t>6/25/25</a:t>
+              <a:t>9/11/25</a:t>
             </a:fld>
             <a:endParaRPr lang="en-US"/>
           </a:p>
@@ -1241,7 +1241,7 @@
           <a:p>
             <a:fld id="{EC25FAA8-77F2-5C42-A9DC-2A9BDE3DA24F}" type="datetimeFigureOut">
               <a:rPr lang="en-US" smtClean="0"/>
-              <a:t>6/25/25</a:t>
+              <a:t>9/11/25</a:t>
             </a:fld>
             <a:endParaRPr lang="en-US"/>
           </a:p>
@@ -1608,7 +1608,7 @@
           <a:p>
             <a:fld id="{EC25FAA8-77F2-5C42-A9DC-2A9BDE3DA24F}" type="datetimeFigureOut">
               <a:rPr lang="en-US" smtClean="0"/>
-              <a:t>6/25/25</a:t>
+              <a:t>9/11/25</a:t>
             </a:fld>
             <a:endParaRPr lang="en-US"/>
           </a:p>
@@ -1726,7 +1726,7 @@
           <a:p>
             <a:fld id="{EC25FAA8-77F2-5C42-A9DC-2A9BDE3DA24F}" type="datetimeFigureOut">
               <a:rPr lang="en-US" smtClean="0"/>
-              <a:t>6/25/25</a:t>
+              <a:t>9/11/25</a:t>
             </a:fld>
             <a:endParaRPr lang="en-US"/>
           </a:p>
@@ -1821,7 +1821,7 @@
           <a:p>
             <a:fld id="{EC25FAA8-77F2-5C42-A9DC-2A9BDE3DA24F}" type="datetimeFigureOut">
               <a:rPr lang="en-US" smtClean="0"/>
-              <a:t>6/25/25</a:t>
+              <a:t>9/11/25</a:t>
             </a:fld>
             <a:endParaRPr lang="en-US"/>
           </a:p>
@@ -2098,7 +2098,7 @@
           <a:p>
             <a:fld id="{EC25FAA8-77F2-5C42-A9DC-2A9BDE3DA24F}" type="datetimeFigureOut">
               <a:rPr lang="en-US" smtClean="0"/>
-              <a:t>6/25/25</a:t>
+              <a:t>9/11/25</a:t>
             </a:fld>
             <a:endParaRPr lang="en-US"/>
           </a:p>
@@ -2355,7 +2355,7 @@
           <a:p>
             <a:fld id="{EC25FAA8-77F2-5C42-A9DC-2A9BDE3DA24F}" type="datetimeFigureOut">
               <a:rPr lang="en-US" smtClean="0"/>
-              <a:t>6/25/25</a:t>
+              <a:t>9/11/25</a:t>
             </a:fld>
             <a:endParaRPr lang="en-US"/>
           </a:p>
@@ -2568,7 +2568,7 @@
           <a:p>
             <a:fld id="{EC25FAA8-77F2-5C42-A9DC-2A9BDE3DA24F}" type="datetimeFigureOut">
               <a:rPr lang="en-US" smtClean="0"/>
-              <a:t>6/25/25</a:t>
+              <a:t>9/11/25</a:t>
             </a:fld>
             <a:endParaRPr lang="en-US"/>
           </a:p>
@@ -4660,12 +4660,64 @@
           </a:p>
         </p:txBody>
       </p:sp>
+      <p:sp>
+        <p:nvSpPr>
+          <p:cNvPr id="108" name="Rectangle 107">
+            <a:extLst>
+              <a:ext uri="{FF2B5EF4-FFF2-40B4-BE49-F238E27FC236}">
+                <a16:creationId xmlns:a16="http://schemas.microsoft.com/office/drawing/2014/main" id="{B8D780DA-8AC7-5FCD-7749-EEA5FC534A31}"/>
+              </a:ext>
+            </a:extLst>
+          </p:cNvPr>
+          <p:cNvSpPr/>
+          <p:nvPr/>
+        </p:nvSpPr>
+        <p:spPr>
+          <a:xfrm>
+            <a:off x="14836199" y="4245749"/>
+            <a:ext cx="1086963" cy="428872"/>
+          </a:xfrm>
+          <a:prstGeom prst="rect">
+            <a:avLst/>
+          </a:prstGeom>
+          <a:solidFill>
+            <a:schemeClr val="bg1"/>
+          </a:solidFill>
+          <a:ln>
+            <a:noFill/>
+          </a:ln>
+        </p:spPr>
+        <p:style>
+          <a:lnRef idx="2">
+            <a:schemeClr val="accent1">
+              <a:shade val="15000"/>
+            </a:schemeClr>
+          </a:lnRef>
+          <a:fillRef idx="1">
+            <a:schemeClr val="accent1"/>
+          </a:fillRef>
+          <a:effectRef idx="0">
+            <a:schemeClr val="accent1"/>
+          </a:effectRef>
+          <a:fontRef idx="minor">
+            <a:schemeClr val="lt1"/>
+          </a:fontRef>
+        </p:style>
+        <p:txBody>
+          <a:bodyPr rtlCol="0" anchor="ctr"/>
+          <a:lstStyle/>
+          <a:p>
+            <a:pPr algn="ctr"/>
+            <a:endParaRPr lang="en-US"/>
+          </a:p>
+        </p:txBody>
+      </p:sp>
       <p:grpSp>
         <p:nvGrpSpPr>
-          <p:cNvPr id="106" name="Group 105">
+          <p:cNvPr id="4" name="Group 3">
             <a:extLst>
               <a:ext uri="{FF2B5EF4-FFF2-40B4-BE49-F238E27FC236}">
-                <a16:creationId xmlns:a16="http://schemas.microsoft.com/office/drawing/2014/main" id="{8EB0E01C-7C82-718E-EBF9-E0D39C2F6C29}"/>
+                <a16:creationId xmlns:a16="http://schemas.microsoft.com/office/drawing/2014/main" id="{579B9D1C-93BF-E47B-CA2F-541DCBB1688A}"/>
               </a:ext>
             </a:extLst>
           </p:cNvPr>
@@ -4676,8 +4728,8 @@
           <a:xfrm>
             <a:off x="11458471" y="276176"/>
             <a:ext cx="9513641" cy="5288204"/>
-            <a:chOff x="12705840" y="925591"/>
-            <a:chExt cx="7643869" cy="3980428"/>
+            <a:chOff x="11458471" y="276176"/>
+            <a:chExt cx="9513641" cy="5288204"/>
           </a:xfrm>
         </p:grpSpPr>
         <p:pic>
@@ -4702,8 +4754,8 @@
           </p:blipFill>
           <p:spPr>
             <a:xfrm>
-              <a:off x="17519892" y="3291599"/>
-              <a:ext cx="1515042" cy="689257"/>
+              <a:off x="17450092" y="3419540"/>
+              <a:ext cx="1885637" cy="915713"/>
             </a:xfrm>
             <a:prstGeom prst="rect">
               <a:avLst/>
@@ -4737,8 +4789,8 @@
           </p:blipFill>
           <p:spPr>
             <a:xfrm>
-              <a:off x="13399838" y="3268660"/>
-              <a:ext cx="1521212" cy="712196"/>
+              <a:off x="12322228" y="3389064"/>
+              <a:ext cx="1893317" cy="946189"/>
             </a:xfrm>
             <a:prstGeom prst="rect">
               <a:avLst/>
@@ -4764,8 +4816,8 @@
           </p:nvGrpSpPr>
           <p:grpSpPr>
             <a:xfrm>
-              <a:off x="12705840" y="925591"/>
-              <a:ext cx="7643869" cy="3980428"/>
+              <a:off x="11458471" y="276176"/>
+              <a:ext cx="9513641" cy="5288204"/>
               <a:chOff x="960976" y="541503"/>
               <a:chExt cx="7643869" cy="3980428"/>
             </a:xfrm>
@@ -5276,33 +5328,17 @@
                         <a:srgbClr val="424242"/>
                       </a:solidFill>
                     </a:rPr>
-                    <a:t>Convergence feature extraction</a:t>
-                  </a:r>
-                  <a:r>
-                    <a:rPr lang="en-US" b="1">
-                      <a:solidFill>
-                        <a:srgbClr val="424242"/>
-                      </a:solidFill>
-                    </a:rPr>
-                    <a:t>. </a:t>
+                    <a:t>Convergence feature extraction. </a:t>
                   </a:r>
                 </a:p>
                 <a:p>
-                  <a:r>
-                    <a:rPr lang="en-US" b="1">
-                      <a:solidFill>
-                        <a:srgbClr val="457499"/>
-                      </a:solidFill>
-                    </a:rPr>
-                    <a:t>Pert</a:t>
-                  </a:r>
                   <a:r>
                     <a:rPr lang="en-US" b="1" dirty="0">
                       <a:solidFill>
                         <a:srgbClr val="457499"/>
                       </a:solidFill>
                     </a:rPr>
-                    <a:t>.2 vs. Control</a:t>
+                    <a:t>Pert.2 vs. Control</a:t>
                   </a:r>
                 </a:p>
               </p:txBody>
@@ -5959,8 +5995,8 @@
           </p:blipFill>
           <p:spPr>
             <a:xfrm>
-              <a:off x="14296367" y="3507814"/>
-              <a:ext cx="1510134" cy="757731"/>
+              <a:off x="13438058" y="3706793"/>
+              <a:ext cx="1879529" cy="1006685"/>
             </a:xfrm>
             <a:prstGeom prst="rect">
               <a:avLst/>
@@ -5986,8 +6022,8 @@
           </p:nvSpPr>
           <p:spPr>
             <a:xfrm>
-              <a:off x="14375610" y="3687597"/>
-              <a:ext cx="838046" cy="277996"/>
+              <a:off x="13536685" y="3945643"/>
+              <a:ext cx="1043041" cy="369332"/>
             </a:xfrm>
             <a:prstGeom prst="rect">
               <a:avLst/>
@@ -6035,8 +6071,8 @@
           </p:blipFill>
           <p:spPr>
             <a:xfrm>
-              <a:off x="18416393" y="3602095"/>
-              <a:ext cx="1515042" cy="757521"/>
+              <a:off x="18565886" y="3832050"/>
+              <a:ext cx="1885637" cy="1006406"/>
             </a:xfrm>
             <a:prstGeom prst="rect">
               <a:avLst/>
@@ -6062,8 +6098,8 @@
           </p:nvSpPr>
           <p:spPr>
             <a:xfrm>
-              <a:off x="18704936" y="3856745"/>
-              <a:ext cx="683235" cy="277996"/>
+              <a:off x="18925010" y="4170365"/>
+              <a:ext cx="850362" cy="369332"/>
             </a:xfrm>
             <a:prstGeom prst="rect">
               <a:avLst/>
@@ -6116,8 +6152,8 @@
           </p:blipFill>
           <p:spPr>
             <a:xfrm>
-              <a:off x="15258405" y="3683302"/>
-              <a:ext cx="1521212" cy="792861"/>
+              <a:off x="14635421" y="3939937"/>
+              <a:ext cx="1893317" cy="1053357"/>
             </a:xfrm>
             <a:prstGeom prst="rect">
               <a:avLst/>
@@ -6129,105 +6165,53 @@
             </a:ln>
           </p:spPr>
         </p:pic>
-      </p:grpSp>
-      <p:sp>
-        <p:nvSpPr>
-          <p:cNvPr id="108" name="Rectangle 107">
-            <a:extLst>
-              <a:ext uri="{FF2B5EF4-FFF2-40B4-BE49-F238E27FC236}">
-                <a16:creationId xmlns:a16="http://schemas.microsoft.com/office/drawing/2014/main" id="{B8D780DA-8AC7-5FCD-7749-EEA5FC534A31}"/>
-              </a:ext>
-            </a:extLst>
-          </p:cNvPr>
-          <p:cNvSpPr/>
-          <p:nvPr/>
-        </p:nvSpPr>
-        <p:spPr>
-          <a:xfrm>
-            <a:off x="14836199" y="4245749"/>
-            <a:ext cx="1086963" cy="428872"/>
-          </a:xfrm>
-          <a:prstGeom prst="rect">
-            <a:avLst/>
-          </a:prstGeom>
-          <a:solidFill>
-            <a:schemeClr val="bg1"/>
-          </a:solidFill>
-          <a:ln>
-            <a:noFill/>
-          </a:ln>
-        </p:spPr>
-        <p:style>
-          <a:lnRef idx="2">
-            <a:schemeClr val="accent1">
-              <a:shade val="15000"/>
-            </a:schemeClr>
-          </a:lnRef>
-          <a:fillRef idx="1">
-            <a:schemeClr val="accent1"/>
-          </a:fillRef>
-          <a:effectRef idx="0">
-            <a:schemeClr val="accent1"/>
-          </a:effectRef>
-          <a:fontRef idx="minor">
-            <a:schemeClr val="lt1"/>
-          </a:fontRef>
-        </p:style>
-        <p:txBody>
-          <a:bodyPr rtlCol="0" anchor="ctr"/>
-          <a:lstStyle/>
-          <a:p>
-            <a:pPr algn="ctr"/>
-            <a:endParaRPr lang="en-US"/>
-          </a:p>
-        </p:txBody>
-      </p:sp>
-      <p:sp>
-        <p:nvSpPr>
-          <p:cNvPr id="109" name="TextBox 108">
-            <a:extLst>
-              <a:ext uri="{FF2B5EF4-FFF2-40B4-BE49-F238E27FC236}">
-                <a16:creationId xmlns:a16="http://schemas.microsoft.com/office/drawing/2014/main" id="{BB49B2D8-3B80-6D14-13E1-A84063420707}"/>
-              </a:ext>
-            </a:extLst>
-          </p:cNvPr>
-          <p:cNvSpPr txBox="1"/>
-          <p:nvPr/>
-        </p:nvSpPr>
-        <p:spPr>
-          <a:xfrm>
-            <a:off x="14843068" y="4260531"/>
-            <a:ext cx="1060427" cy="369332"/>
-          </a:xfrm>
-          <a:prstGeom prst="rect">
-            <a:avLst/>
-          </a:prstGeom>
-          <a:solidFill>
-            <a:schemeClr val="bg1"/>
-          </a:solidFill>
-        </p:spPr>
-        <p:txBody>
-          <a:bodyPr wrap="square" rtlCol="0">
-            <a:spAutoFit/>
-          </a:bodyPr>
-          <a:lstStyle/>
-          <a:p>
-            <a:r>
-              <a:rPr lang="en-US" b="1" dirty="0">
+        <p:sp>
+          <p:nvSpPr>
+            <p:cNvPr id="109" name="TextBox 108">
+              <a:extLst>
+                <a:ext uri="{FF2B5EF4-FFF2-40B4-BE49-F238E27FC236}">
+                  <a16:creationId xmlns:a16="http://schemas.microsoft.com/office/drawing/2014/main" id="{BB49B2D8-3B80-6D14-13E1-A84063420707}"/>
+                </a:ext>
+              </a:extLst>
+            </p:cNvPr>
+            <p:cNvSpPr txBox="1"/>
+            <p:nvPr/>
+          </p:nvSpPr>
+          <p:spPr>
+            <a:xfrm>
+              <a:off x="14843068" y="4260531"/>
+              <a:ext cx="1060427" cy="369332"/>
+            </a:xfrm>
+            <a:prstGeom prst="rect">
+              <a:avLst/>
+            </a:prstGeom>
+            <a:solidFill>
+              <a:schemeClr val="bg1"/>
+            </a:solidFill>
+          </p:spPr>
+          <p:txBody>
+            <a:bodyPr wrap="square" rtlCol="0">
+              <a:spAutoFit/>
+            </a:bodyPr>
+            <a:lstStyle/>
+            <a:p>
+              <a:r>
+                <a:rPr lang="en-US" b="1" dirty="0">
+                  <a:solidFill>
+                    <a:srgbClr val="457499"/>
+                  </a:solidFill>
+                </a:rPr>
+                <a:t>Pert. 2</a:t>
+              </a:r>
+              <a:endParaRPr lang="en-US" sz="2000" b="1" dirty="0">
                 <a:solidFill>
                   <a:srgbClr val="457499"/>
                 </a:solidFill>
-              </a:rPr>
-              <a:t>Pert. 2</a:t>
-            </a:r>
-            <a:endParaRPr lang="en-US" sz="2000" b="1" dirty="0">
-              <a:solidFill>
-                <a:srgbClr val="457499"/>
-              </a:solidFill>
-            </a:endParaRPr>
-          </a:p>
-        </p:txBody>
-      </p:sp>
+              </a:endParaRPr>
+            </a:p>
+          </p:txBody>
+        </p:sp>
+      </p:grpSp>
     </p:spTree>
     <p:extLst>
       <p:ext uri="{BB962C8B-B14F-4D97-AF65-F5344CB8AC3E}">

</xml_diff>